<commit_message>
test(pptx): append picture added to placeholder
Signed-off-by: Cesar Berrospi Ramis <ceb@zurich.ibm.com>
</commit_message>
<xml_diff>
--- a/tests/data/pptx/sources/powerpoint_with_image.pptx
+++ b/tests/data/pptx/sources/powerpoint_with_image.pptx
@@ -6,6 +6,7 @@
   </p:sldMasterIdLst>
   <p:sldIdLst>
     <p:sldId id="256" r:id="rId2"/>
+    <p:sldId id="257" r:id="rId3"/>
   </p:sldIdLst>
   <p:sldSz cx="12192000" cy="6858000"/>
   <p:notesSz cx="6858000" cy="9144000"/>
@@ -259,7 +260,7 @@
           <a:p>
             <a:fld id="{22C88FD7-B5A4-B541-9894-CD062EA3E37C}" type="datetimeFigureOut">
               <a:rPr lang="en-US" smtClean="0"/>
-              <a:t>1/30/26</a:t>
+              <a:t>10/5/26</a:t>
             </a:fld>
             <a:endParaRPr lang="en-US"/>
           </a:p>
@@ -457,7 +458,7 @@
           <a:p>
             <a:fld id="{22C88FD7-B5A4-B541-9894-CD062EA3E37C}" type="datetimeFigureOut">
               <a:rPr lang="en-US" smtClean="0"/>
-              <a:t>1/30/26</a:t>
+              <a:t>10/5/26</a:t>
             </a:fld>
             <a:endParaRPr lang="en-US"/>
           </a:p>
@@ -665,7 +666,7 @@
           <a:p>
             <a:fld id="{22C88FD7-B5A4-B541-9894-CD062EA3E37C}" type="datetimeFigureOut">
               <a:rPr lang="en-US" smtClean="0"/>
-              <a:t>1/30/26</a:t>
+              <a:t>10/5/26</a:t>
             </a:fld>
             <a:endParaRPr lang="en-US"/>
           </a:p>
@@ -863,7 +864,7 @@
           <a:p>
             <a:fld id="{22C88FD7-B5A4-B541-9894-CD062EA3E37C}" type="datetimeFigureOut">
               <a:rPr lang="en-US" smtClean="0"/>
-              <a:t>1/30/26</a:t>
+              <a:t>10/5/26</a:t>
             </a:fld>
             <a:endParaRPr lang="en-US"/>
           </a:p>
@@ -1138,7 +1139,7 @@
           <a:p>
             <a:fld id="{22C88FD7-B5A4-B541-9894-CD062EA3E37C}" type="datetimeFigureOut">
               <a:rPr lang="en-US" smtClean="0"/>
-              <a:t>1/30/26</a:t>
+              <a:t>10/5/26</a:t>
             </a:fld>
             <a:endParaRPr lang="en-US"/>
           </a:p>
@@ -1403,7 +1404,7 @@
           <a:p>
             <a:fld id="{22C88FD7-B5A4-B541-9894-CD062EA3E37C}" type="datetimeFigureOut">
               <a:rPr lang="en-US" smtClean="0"/>
-              <a:t>1/30/26</a:t>
+              <a:t>10/5/26</a:t>
             </a:fld>
             <a:endParaRPr lang="en-US"/>
           </a:p>
@@ -1815,7 +1816,7 @@
           <a:p>
             <a:fld id="{22C88FD7-B5A4-B541-9894-CD062EA3E37C}" type="datetimeFigureOut">
               <a:rPr lang="en-US" smtClean="0"/>
-              <a:t>1/30/26</a:t>
+              <a:t>10/5/26</a:t>
             </a:fld>
             <a:endParaRPr lang="en-US"/>
           </a:p>
@@ -1956,7 +1957,7 @@
           <a:p>
             <a:fld id="{22C88FD7-B5A4-B541-9894-CD062EA3E37C}" type="datetimeFigureOut">
               <a:rPr lang="en-US" smtClean="0"/>
-              <a:t>1/30/26</a:t>
+              <a:t>10/5/26</a:t>
             </a:fld>
             <a:endParaRPr lang="en-US"/>
           </a:p>
@@ -2069,7 +2070,7 @@
           <a:p>
             <a:fld id="{22C88FD7-B5A4-B541-9894-CD062EA3E37C}" type="datetimeFigureOut">
               <a:rPr lang="en-US" smtClean="0"/>
-              <a:t>1/30/26</a:t>
+              <a:t>10/5/26</a:t>
             </a:fld>
             <a:endParaRPr lang="en-US"/>
           </a:p>
@@ -2380,7 +2381,7 @@
           <a:p>
             <a:fld id="{22C88FD7-B5A4-B541-9894-CD062EA3E37C}" type="datetimeFigureOut">
               <a:rPr lang="en-US" smtClean="0"/>
-              <a:t>1/30/26</a:t>
+              <a:t>10/5/26</a:t>
             </a:fld>
             <a:endParaRPr lang="en-US"/>
           </a:p>
@@ -2668,7 +2669,7 @@
           <a:p>
             <a:fld id="{22C88FD7-B5A4-B541-9894-CD062EA3E37C}" type="datetimeFigureOut">
               <a:rPr lang="en-US" smtClean="0"/>
-              <a:t>1/30/26</a:t>
+              <a:t>10/5/26</a:t>
             </a:fld>
             <a:endParaRPr lang="en-US"/>
           </a:p>
@@ -2909,7 +2910,7 @@
           <a:p>
             <a:fld id="{22C88FD7-B5A4-B541-9894-CD062EA3E37C}" type="datetimeFigureOut">
               <a:rPr lang="en-US" smtClean="0"/>
-              <a:t>1/30/26</a:t>
+              <a:t>10/5/26</a:t>
             </a:fld>
             <a:endParaRPr lang="en-US"/>
           </a:p>
@@ -3665,6 +3666,96 @@
 </p:sld>
 </file>
 
+<file path=ppt/slides/slide2.xml><?xml version="1.0" encoding="utf-8"?>
+<p:sld xmlns:a="http://schemas.openxmlformats.org/drawingml/2006/main" xmlns:r="http://schemas.openxmlformats.org/officeDocument/2006/relationships" xmlns:p="http://schemas.openxmlformats.org/presentationml/2006/main">
+  <p:cSld>
+    <p:spTree>
+      <p:nvGrpSpPr>
+        <p:cNvPr id="1" name=""/>
+        <p:cNvGrpSpPr/>
+        <p:nvPr/>
+      </p:nvGrpSpPr>
+      <p:grpSpPr>
+        <a:xfrm>
+          <a:off x="0" y="0"/>
+          <a:ext cx="0" cy="0"/>
+          <a:chOff x="0" y="0"/>
+          <a:chExt cx="0" cy="0"/>
+        </a:xfrm>
+      </p:grpSpPr>
+      <p:sp>
+        <p:nvSpPr>
+          <p:cNvPr id="2" name="Title 1"/>
+          <p:cNvSpPr>
+            <a:spLocks noGrp="1"/>
+          </p:cNvSpPr>
+          <p:nvPr>
+            <p:ph type="title"/>
+          </p:nvPr>
+        </p:nvSpPr>
+        <p:spPr/>
+        <p:txBody>
+          <a:bodyPr/>
+          <a:lstStyle/>
+          <a:p>
+            <a:r>
+              <a:rPr lang="en-US" dirty="0"/>
+              <a:t>Picture placeholder</a:t>
+            </a:r>
+            <a:endParaRPr dirty="0"/>
+          </a:p>
+        </p:txBody>
+      </p:sp>
+      <p:pic>
+        <p:nvPicPr>
+          <p:cNvPr id="3" name="Picture Placeholder 2" descr="image.png"/>
+          <p:cNvPicPr>
+            <a:picLocks noGrp="1" noChangeAspect="1"/>
+          </p:cNvPicPr>
+          <p:nvPr>
+            <p:ph type="pic" idx="1"/>
+          </p:nvPr>
+        </p:nvPicPr>
+        <p:blipFill>
+          <a:blip r:embed="rId2"/>
+          <a:srcRect l="18339" r="18339"/>
+          <a:stretch>
+            <a:fillRect/>
+          </a:stretch>
+        </p:blipFill>
+        <p:spPr/>
+      </p:pic>
+      <p:sp>
+        <p:nvSpPr>
+          <p:cNvPr id="4" name="Text Placeholder 3"/>
+          <p:cNvSpPr>
+            <a:spLocks noGrp="1"/>
+          </p:cNvSpPr>
+          <p:nvPr>
+            <p:ph type="body" sz="half" idx="2"/>
+          </p:nvPr>
+        </p:nvSpPr>
+        <p:spPr/>
+        <p:txBody>
+          <a:bodyPr/>
+          <a:lstStyle/>
+          <a:p>
+            <a:r>
+              <a:rPr lang="en-US" dirty="0"/>
+              <a:t>This is a picture inserted through a layout’s picture placeholder</a:t>
+            </a:r>
+            <a:endParaRPr dirty="0"/>
+          </a:p>
+        </p:txBody>
+      </p:sp>
+    </p:spTree>
+  </p:cSld>
+  <p:clrMapOvr>
+    <a:masterClrMapping/>
+  </p:clrMapOvr>
+</p:sld>
+</file>
+
 <file path=ppt/theme/theme1.xml><?xml version="1.0" encoding="utf-8"?>
 <a:theme xmlns:a="http://schemas.openxmlformats.org/drawingml/2006/main" name="Office Theme">
   <a:themeElements>

</xml_diff>

<commit_message>
fix(pptx): extract pictures from picture placeholders (#4594)
* fix(pptx): extract pictures from picture placeholders

Signed-off-by: Cesar Berrospi Ramis <ceb@zurich.ibm.com>

* test(pptx): append picture added to placeholder

Signed-off-by: Cesar Berrospi Ramis <ceb@zurich.ibm.com>

---------

Signed-off-by: Cesar Berrospi Ramis <ceb@zurich.ibm.com>
</commit_message>
<xml_diff>
--- a/tests/data/pptx/sources/powerpoint_with_image.pptx
+++ b/tests/data/pptx/sources/powerpoint_with_image.pptx
@@ -6,6 +6,7 @@
   </p:sldMasterIdLst>
   <p:sldIdLst>
     <p:sldId id="256" r:id="rId2"/>
+    <p:sldId id="257" r:id="rId3"/>
   </p:sldIdLst>
   <p:sldSz cx="12192000" cy="6858000"/>
   <p:notesSz cx="6858000" cy="9144000"/>
@@ -259,7 +260,7 @@
           <a:p>
             <a:fld id="{22C88FD7-B5A4-B541-9894-CD062EA3E37C}" type="datetimeFigureOut">
               <a:rPr lang="en-US" smtClean="0"/>
-              <a:t>1/30/26</a:t>
+              <a:t>10/5/26</a:t>
             </a:fld>
             <a:endParaRPr lang="en-US"/>
           </a:p>
@@ -457,7 +458,7 @@
           <a:p>
             <a:fld id="{22C88FD7-B5A4-B541-9894-CD062EA3E37C}" type="datetimeFigureOut">
               <a:rPr lang="en-US" smtClean="0"/>
-              <a:t>1/30/26</a:t>
+              <a:t>10/5/26</a:t>
             </a:fld>
             <a:endParaRPr lang="en-US"/>
           </a:p>
@@ -665,7 +666,7 @@
           <a:p>
             <a:fld id="{22C88FD7-B5A4-B541-9894-CD062EA3E37C}" type="datetimeFigureOut">
               <a:rPr lang="en-US" smtClean="0"/>
-              <a:t>1/30/26</a:t>
+              <a:t>10/5/26</a:t>
             </a:fld>
             <a:endParaRPr lang="en-US"/>
           </a:p>
@@ -863,7 +864,7 @@
           <a:p>
             <a:fld id="{22C88FD7-B5A4-B541-9894-CD062EA3E37C}" type="datetimeFigureOut">
               <a:rPr lang="en-US" smtClean="0"/>
-              <a:t>1/30/26</a:t>
+              <a:t>10/5/26</a:t>
             </a:fld>
             <a:endParaRPr lang="en-US"/>
           </a:p>
@@ -1138,7 +1139,7 @@
           <a:p>
             <a:fld id="{22C88FD7-B5A4-B541-9894-CD062EA3E37C}" type="datetimeFigureOut">
               <a:rPr lang="en-US" smtClean="0"/>
-              <a:t>1/30/26</a:t>
+              <a:t>10/5/26</a:t>
             </a:fld>
             <a:endParaRPr lang="en-US"/>
           </a:p>
@@ -1403,7 +1404,7 @@
           <a:p>
             <a:fld id="{22C88FD7-B5A4-B541-9894-CD062EA3E37C}" type="datetimeFigureOut">
               <a:rPr lang="en-US" smtClean="0"/>
-              <a:t>1/30/26</a:t>
+              <a:t>10/5/26</a:t>
             </a:fld>
             <a:endParaRPr lang="en-US"/>
           </a:p>
@@ -1815,7 +1816,7 @@
           <a:p>
             <a:fld id="{22C88FD7-B5A4-B541-9894-CD062EA3E37C}" type="datetimeFigureOut">
               <a:rPr lang="en-US" smtClean="0"/>
-              <a:t>1/30/26</a:t>
+              <a:t>10/5/26</a:t>
             </a:fld>
             <a:endParaRPr lang="en-US"/>
           </a:p>
@@ -1956,7 +1957,7 @@
           <a:p>
             <a:fld id="{22C88FD7-B5A4-B541-9894-CD062EA3E37C}" type="datetimeFigureOut">
               <a:rPr lang="en-US" smtClean="0"/>
-              <a:t>1/30/26</a:t>
+              <a:t>10/5/26</a:t>
             </a:fld>
             <a:endParaRPr lang="en-US"/>
           </a:p>
@@ -2069,7 +2070,7 @@
           <a:p>
             <a:fld id="{22C88FD7-B5A4-B541-9894-CD062EA3E37C}" type="datetimeFigureOut">
               <a:rPr lang="en-US" smtClean="0"/>
-              <a:t>1/30/26</a:t>
+              <a:t>10/5/26</a:t>
             </a:fld>
             <a:endParaRPr lang="en-US"/>
           </a:p>
@@ -2380,7 +2381,7 @@
           <a:p>
             <a:fld id="{22C88FD7-B5A4-B541-9894-CD062EA3E37C}" type="datetimeFigureOut">
               <a:rPr lang="en-US" smtClean="0"/>
-              <a:t>1/30/26</a:t>
+              <a:t>10/5/26</a:t>
             </a:fld>
             <a:endParaRPr lang="en-US"/>
           </a:p>
@@ -2668,7 +2669,7 @@
           <a:p>
             <a:fld id="{22C88FD7-B5A4-B541-9894-CD062EA3E37C}" type="datetimeFigureOut">
               <a:rPr lang="en-US" smtClean="0"/>
-              <a:t>1/30/26</a:t>
+              <a:t>10/5/26</a:t>
             </a:fld>
             <a:endParaRPr lang="en-US"/>
           </a:p>
@@ -2909,7 +2910,7 @@
           <a:p>
             <a:fld id="{22C88FD7-B5A4-B541-9894-CD062EA3E37C}" type="datetimeFigureOut">
               <a:rPr lang="en-US" smtClean="0"/>
-              <a:t>1/30/26</a:t>
+              <a:t>10/5/26</a:t>
             </a:fld>
             <a:endParaRPr lang="en-US"/>
           </a:p>
@@ -3665,6 +3666,96 @@
 </p:sld>
 </file>
 
+<file path=ppt/slides/slide2.xml><?xml version="1.0" encoding="utf-8"?>
+<p:sld xmlns:a="http://schemas.openxmlformats.org/drawingml/2006/main" xmlns:r="http://schemas.openxmlformats.org/officeDocument/2006/relationships" xmlns:p="http://schemas.openxmlformats.org/presentationml/2006/main">
+  <p:cSld>
+    <p:spTree>
+      <p:nvGrpSpPr>
+        <p:cNvPr id="1" name=""/>
+        <p:cNvGrpSpPr/>
+        <p:nvPr/>
+      </p:nvGrpSpPr>
+      <p:grpSpPr>
+        <a:xfrm>
+          <a:off x="0" y="0"/>
+          <a:ext cx="0" cy="0"/>
+          <a:chOff x="0" y="0"/>
+          <a:chExt cx="0" cy="0"/>
+        </a:xfrm>
+      </p:grpSpPr>
+      <p:sp>
+        <p:nvSpPr>
+          <p:cNvPr id="2" name="Title 1"/>
+          <p:cNvSpPr>
+            <a:spLocks noGrp="1"/>
+          </p:cNvSpPr>
+          <p:nvPr>
+            <p:ph type="title"/>
+          </p:nvPr>
+        </p:nvSpPr>
+        <p:spPr/>
+        <p:txBody>
+          <a:bodyPr/>
+          <a:lstStyle/>
+          <a:p>
+            <a:r>
+              <a:rPr lang="en-US" dirty="0"/>
+              <a:t>Picture placeholder</a:t>
+            </a:r>
+            <a:endParaRPr dirty="0"/>
+          </a:p>
+        </p:txBody>
+      </p:sp>
+      <p:pic>
+        <p:nvPicPr>
+          <p:cNvPr id="3" name="Picture Placeholder 2" descr="image.png"/>
+          <p:cNvPicPr>
+            <a:picLocks noGrp="1" noChangeAspect="1"/>
+          </p:cNvPicPr>
+          <p:nvPr>
+            <p:ph type="pic" idx="1"/>
+          </p:nvPr>
+        </p:nvPicPr>
+        <p:blipFill>
+          <a:blip r:embed="rId2"/>
+          <a:srcRect l="18339" r="18339"/>
+          <a:stretch>
+            <a:fillRect/>
+          </a:stretch>
+        </p:blipFill>
+        <p:spPr/>
+      </p:pic>
+      <p:sp>
+        <p:nvSpPr>
+          <p:cNvPr id="4" name="Text Placeholder 3"/>
+          <p:cNvSpPr>
+            <a:spLocks noGrp="1"/>
+          </p:cNvSpPr>
+          <p:nvPr>
+            <p:ph type="body" sz="half" idx="2"/>
+          </p:nvPr>
+        </p:nvSpPr>
+        <p:spPr/>
+        <p:txBody>
+          <a:bodyPr/>
+          <a:lstStyle/>
+          <a:p>
+            <a:r>
+              <a:rPr lang="en-US" dirty="0"/>
+              <a:t>This is a picture inserted through a layout’s picture placeholder</a:t>
+            </a:r>
+            <a:endParaRPr dirty="0"/>
+          </a:p>
+        </p:txBody>
+      </p:sp>
+    </p:spTree>
+  </p:cSld>
+  <p:clrMapOvr>
+    <a:masterClrMapping/>
+  </p:clrMapOvr>
+</p:sld>
+</file>
+
 <file path=ppt/theme/theme1.xml><?xml version="1.0" encoding="utf-8"?>
 <a:theme xmlns:a="http://schemas.openxmlformats.org/drawingml/2006/main" name="Office Theme">
   <a:themeElements>

</xml_diff>